<commit_message>
Update email domain and rename to Jubilee Medical
</commit_message>
<xml_diff>
--- a/Jubilee_Med_Pitch_Deck.pptx
+++ b/Jubilee_Med_Pitch_Deck.pptx
@@ -1987,7 +1987,7 @@
                 <a:ea typeface="Aptos Display" pitchFamily="34" charset="-122"/>
                 <a:cs typeface="Aptos Display" pitchFamily="34" charset="-120"/>
               </a:rPr>
-              <a:t>Jubilee Med</a:t>
+              <a:t>Jubilee Medical</a:t>
             </a:r>
             <a:endParaRPr lang="en-US" sz="1800" dirty="0"/>
           </a:p>
@@ -2026,7 +2026,7 @@
                 <a:ea typeface="Aptos Display" pitchFamily="34" charset="-122"/>
                 <a:cs typeface="Aptos Display" pitchFamily="34" charset="-120"/>
               </a:rPr>
-              <a:t>Jubilee Med</a:t>
+              <a:t>Jubilee Medical</a:t>
             </a:r>
             <a:endParaRPr lang="en-US" sz="4200" dirty="0"/>
           </a:p>
@@ -2441,7 +2441,7 @@
                 <a:ea typeface="Aptos Display" pitchFamily="34" charset="-122"/>
                 <a:cs typeface="Aptos Display" pitchFamily="34" charset="-120"/>
               </a:rPr>
-              <a:t>Jubilee Med</a:t>
+              <a:t>Jubilee Medical</a:t>
             </a:r>
             <a:endParaRPr lang="en-US" sz="1800" dirty="0"/>
           </a:p>
@@ -2556,7 +2556,7 @@
                   <a:srgbClr val="5C6F6A"/>
                 </a:solidFill>
               </a:rPr>
-              <a:t>Jubilee Med needs product completion, compliance review, pilot partners, and launch support to move from beta concept to live healthcare operations.</a:t>
+              <a:t>Jubilee Medical needs product completion, compliance review, pilot partners, and launch support to move from beta concept to live healthcare operations.</a:t>
             </a:r>
             <a:endParaRPr lang="en-US" sz="1300" dirty="0"/>
           </a:p>
@@ -3003,7 +3003,7 @@
                   <a:srgbClr val="FFFFFF"/>
                 </a:solidFill>
               </a:rPr>
-              <a:t>hello@jubileemed.ng  |  +234 800 000 0000  |  Lagos, Nigeria</a:t>
+              <a:t>hello@jubileemedical.health  |  +234 800 000 0000  |  Lagos, Nigeria</a:t>
             </a:r>
             <a:endParaRPr lang="en-US" sz="1200" dirty="0"/>
           </a:p>
@@ -3062,7 +3062,7 @@
                   <a:srgbClr val="5C6F6A"/>
                 </a:solidFill>
               </a:rPr>
-              <a:t>Jubilee Med | Digital health made clear</a:t>
+              <a:t>Jubilee Medical | Digital health made clear</a:t>
             </a:r>
             <a:endParaRPr lang="en-US" sz="800" dirty="0"/>
           </a:p>
@@ -3273,7 +3273,7 @@
                 <a:ea typeface="Aptos Display" pitchFamily="34" charset="-122"/>
                 <a:cs typeface="Aptos Display" pitchFamily="34" charset="-120"/>
               </a:rPr>
-              <a:t>Jubilee Med</a:t>
+              <a:t>Jubilee Medical</a:t>
             </a:r>
             <a:endParaRPr lang="en-US" sz="1800" dirty="0"/>
           </a:p>
@@ -3959,7 +3959,7 @@
                   <a:srgbClr val="5C6F6A"/>
                 </a:solidFill>
               </a:rPr>
-              <a:t>Jubilee Med | Digital health made clear</a:t>
+              <a:t>Jubilee Medical | Digital health made clear</a:t>
             </a:r>
             <a:endParaRPr lang="en-US" sz="800" dirty="0"/>
           </a:p>
@@ -4170,7 +4170,7 @@
                 <a:ea typeface="Aptos Display" pitchFamily="34" charset="-122"/>
                 <a:cs typeface="Aptos Display" pitchFamily="34" charset="-120"/>
               </a:rPr>
-              <a:t>Jubilee Med</a:t>
+              <a:t>Jubilee Medical</a:t>
             </a:r>
             <a:endParaRPr lang="en-US" sz="1800" dirty="0"/>
           </a:p>
@@ -4285,7 +4285,7 @@
                   <a:srgbClr val="5C6F6A"/>
                 </a:solidFill>
               </a:rPr>
-              <a:t>Jubilee Med gives patients one front door for care and gives providers a practical workspace for appointments, EHR, billing, pharmacy, labs, and reports.</a:t>
+              <a:t>Jubilee Medical gives patients one front door for care and gives providers a practical workspace for appointments, EHR, billing, pharmacy, labs, and reports.</a:t>
             </a:r>
             <a:endParaRPr lang="en-US" sz="1300" dirty="0"/>
           </a:p>
@@ -4706,7 +4706,7 @@
                   <a:srgbClr val="5C6F6A"/>
                 </a:solidFill>
               </a:rPr>
-              <a:t>Jubilee Med | Digital health made clear</a:t>
+              <a:t>Jubilee Medical | Digital health made clear</a:t>
             </a:r>
             <a:endParaRPr lang="en-US" sz="800" dirty="0"/>
           </a:p>
@@ -4917,7 +4917,7 @@
                 <a:ea typeface="Aptos Display" pitchFamily="34" charset="-122"/>
                 <a:cs typeface="Aptos Display" pitchFamily="34" charset="-120"/>
               </a:rPr>
-              <a:t>Jubilee Med</a:t>
+              <a:t>Jubilee Medical</a:t>
             </a:r>
             <a:endParaRPr lang="en-US" sz="1800" dirty="0"/>
           </a:p>
@@ -5859,7 +5859,7 @@
                   <a:srgbClr val="5C6F6A"/>
                 </a:solidFill>
               </a:rPr>
-              <a:t>Jubilee Med | Digital health made clear</a:t>
+              <a:t>Jubilee Medical | Digital health made clear</a:t>
             </a:r>
             <a:endParaRPr lang="en-US" sz="800" dirty="0"/>
           </a:p>
@@ -6070,7 +6070,7 @@
                 <a:ea typeface="Aptos Display" pitchFamily="34" charset="-122"/>
                 <a:cs typeface="Aptos Display" pitchFamily="34" charset="-120"/>
               </a:rPr>
-              <a:t>Jubilee Med</a:t>
+              <a:t>Jubilee Medical</a:t>
             </a:r>
             <a:endParaRPr lang="en-US" sz="1800" dirty="0"/>
           </a:p>
@@ -6730,7 +6730,7 @@
                   <a:srgbClr val="5C6F6A"/>
                 </a:solidFill>
               </a:rPr>
-              <a:t>Jubilee Med | Digital health made clear</a:t>
+              <a:t>Jubilee Medical | Digital health made clear</a:t>
             </a:r>
             <a:endParaRPr lang="en-US" sz="800" dirty="0"/>
           </a:p>
@@ -6941,7 +6941,7 @@
                 <a:ea typeface="Aptos Display" pitchFamily="34" charset="-122"/>
                 <a:cs typeface="Aptos Display" pitchFamily="34" charset="-120"/>
               </a:rPr>
-              <a:t>Jubilee Med</a:t>
+              <a:t>Jubilee Medical</a:t>
             </a:r>
             <a:endParaRPr lang="en-US" sz="1800" dirty="0"/>
           </a:p>
@@ -7056,7 +7056,7 @@
                   <a:srgbClr val="5C6F6A"/>
                 </a:solidFill>
               </a:rPr>
-              <a:t>Jubilee Med supports the way a clinic actually works from reception to consultation, billing, fulfilment, and reporting.</a:t>
+              <a:t>Jubilee Medical supports the way a clinic actually works from reception to consultation, billing, fulfilment, and reporting.</a:t>
             </a:r>
             <a:endParaRPr lang="en-US" sz="1300" dirty="0"/>
           </a:p>
@@ -7822,7 +7822,7 @@
                   <a:srgbClr val="5C6F6A"/>
                 </a:solidFill>
               </a:rPr>
-              <a:t>Jubilee Med | Digital health made clear</a:t>
+              <a:t>Jubilee Medical | Digital health made clear</a:t>
             </a:r>
             <a:endParaRPr lang="en-US" sz="800" dirty="0"/>
           </a:p>
@@ -8033,7 +8033,7 @@
                 <a:ea typeface="Aptos Display" pitchFamily="34" charset="-122"/>
                 <a:cs typeface="Aptos Display" pitchFamily="34" charset="-120"/>
               </a:rPr>
-              <a:t>Jubilee Med</a:t>
+              <a:t>Jubilee Medical</a:t>
             </a:r>
             <a:endParaRPr lang="en-US" sz="1800" dirty="0"/>
           </a:p>
@@ -8148,7 +8148,7 @@
                   <a:srgbClr val="5C6F6A"/>
                 </a:solidFill>
               </a:rPr>
-              <a:t>Jubilee Med starts with Nigeria and focuses on providers and patients who need affordable, easy-to-understand tools that fit daily care delivery.</a:t>
+              <a:t>Jubilee Medical starts with Nigeria and focuses on providers and patients who need affordable, easy-to-understand tools that fit daily care delivery.</a:t>
             </a:r>
             <a:endParaRPr lang="en-US" sz="1300" dirty="0"/>
           </a:p>
@@ -8564,7 +8564,7 @@
                   <a:srgbClr val="5C6F6A"/>
                 </a:solidFill>
               </a:rPr>
-              <a:t>Jubilee Med | Digital health made clear</a:t>
+              <a:t>Jubilee Medical | Digital health made clear</a:t>
             </a:r>
             <a:endParaRPr lang="en-US" sz="800" dirty="0"/>
           </a:p>
@@ -8775,7 +8775,7 @@
                 <a:ea typeface="Aptos Display" pitchFamily="34" charset="-122"/>
                 <a:cs typeface="Aptos Display" pitchFamily="34" charset="-120"/>
               </a:rPr>
-              <a:t>Jubilee Med</a:t>
+              <a:t>Jubilee Medical</a:t>
             </a:r>
             <a:endParaRPr lang="en-US" sz="1800" dirty="0"/>
           </a:p>
@@ -9461,7 +9461,7 @@
                   <a:srgbClr val="5C6F6A"/>
                 </a:solidFill>
               </a:rPr>
-              <a:t>Jubilee Med | Digital health made clear</a:t>
+              <a:t>Jubilee Medical | Digital health made clear</a:t>
             </a:r>
             <a:endParaRPr lang="en-US" sz="800" dirty="0"/>
           </a:p>
@@ -9672,7 +9672,7 @@
                 <a:ea typeface="Aptos Display" pitchFamily="34" charset="-122"/>
                 <a:cs typeface="Aptos Display" pitchFamily="34" charset="-120"/>
               </a:rPr>
-              <a:t>Jubilee Med</a:t>
+              <a:t>Jubilee Medical</a:t>
             </a:r>
             <a:endParaRPr lang="en-US" sz="1800" dirty="0"/>
           </a:p>
@@ -10332,7 +10332,7 @@
                   <a:srgbClr val="5C6F6A"/>
                 </a:solidFill>
               </a:rPr>
-              <a:t>Jubilee Med | Digital health made clear</a:t>
+              <a:t>Jubilee Medical | Digital health made clear</a:t>
             </a:r>
             <a:endParaRPr lang="en-US" sz="800" dirty="0"/>
           </a:p>

</xml_diff>